<commit_message>
Update proposal PPTX: Moore Christoff & Siddiqui (May 20, 2026)
Refresh competitor data to match updated research notes: Robinson Law
(266 reviews), PNA Law (250), Nova Defenders (490 Birdeye).

Co-Authored-By: Claude Sonnet 4.6 <noreply@anthropic.com>
</commit_message>
<xml_diff>
--- a/moore-christoff-siddiqui/Moore_Christoff_Siddiqui_05202026_Proposal.pptx
+++ b/moore-christoff-siddiqui/Moore_Christoff_Siddiqui_05202026_Proposal.pptx
@@ -4453,7 +4453,7 @@
                 </a:solidFill>
                 <a:latin typeface="Calibri"/>
               </a:rPr>
-              <a:t>PNA Law and Price Benowitz hold LSA and 3-pack — MCS has zero paid presence</a:t>
+              <a:t>Robinson Law (266 reviews) and PNA Law (250) run ads MCS isn't running yet</a:t>
             </a:r>
           </a:p>
         </p:txBody>
@@ -5077,7 +5077,7 @@
                 </a:solidFill>
                 <a:latin typeface="Calibri"/>
               </a:rPr>
-              <a:t>Price Benowitz LLP</a:t>
+              <a:t>Robinson Law, PLLC</a:t>
             </a:r>
           </a:p>
         </p:txBody>
@@ -5110,7 +5110,7 @@
                 </a:solidFill>
                 <a:latin typeface="Calibri"/>
               </a:rPr>
-              <a:t>422 reviews · 4.9★</a:t>
+              <a:t>266 reviews · 4.97★</a:t>
             </a:r>
           </a:p>
         </p:txBody>
@@ -5143,7 +5143,7 @@
                 </a:solidFill>
                 <a:latin typeface="Calibri"/>
               </a:rPr>
-              <a:t>Same Fairfax bldg · multi-channel</a:t>
+              <a:t>Fairfax · Google Ads · 6× MCS count</a:t>
             </a:r>
           </a:p>
         </p:txBody>
@@ -5254,7 +5254,7 @@
                 </a:solidFill>
                 <a:latin typeface="Calibri"/>
               </a:rPr>
-              <a:t>103 reviews · 4.9★</a:t>
+              <a:t>250 reviews · 4.9★</a:t>
             </a:r>
           </a:p>
         </p:txBody>
@@ -5365,7 +5365,7 @@
                 </a:solidFill>
                 <a:latin typeface="Calibri"/>
               </a:rPr>
-              <a:t>Medvin Law</a:t>
+              <a:t>Nova Defenders</a:t>
             </a:r>
           </a:p>
         </p:txBody>
@@ -5398,7 +5398,7 @@
                 </a:solidFill>
                 <a:latin typeface="Calibri"/>
               </a:rPr>
-              <a:t> 81 reviews · 5.0★</a:t>
+              <a:t>490 Birdeye · 4.9★</a:t>
             </a:r>
           </a:p>
         </p:txBody>
@@ -5431,7 +5431,7 @@
                 </a:solidFill>
                 <a:latin typeface="Calibri"/>
               </a:rPr>
-              <a:t>Maps dominant · Alexandria criminal</a:t>
+              <a:t>Fairfax · near courthouse · dominant</a:t>
             </a:r>
           </a:p>
         </p:txBody>

</xml_diff>